<commit_message>
calculos en el frontend
</commit_message>
<xml_diff>
--- a/DOC/Elevaton Pitch Septiembre.pptx
+++ b/DOC/Elevaton Pitch Septiembre.pptx
@@ -5,36 +5,35 @@
     <p:sldMasterId id="2147483659" r:id="rId1"/>
   </p:sldMasterIdLst>
   <p:notesMasterIdLst>
-    <p:notesMasterId r:id="rId12"/>
+    <p:notesMasterId r:id="rId11"/>
   </p:notesMasterIdLst>
   <p:sldIdLst>
     <p:sldId id="256" r:id="rId2"/>
     <p:sldId id="257" r:id="rId3"/>
     <p:sldId id="272" r:id="rId4"/>
     <p:sldId id="259" r:id="rId5"/>
-    <p:sldId id="262" r:id="rId6"/>
-    <p:sldId id="276" r:id="rId7"/>
-    <p:sldId id="278" r:id="rId8"/>
-    <p:sldId id="263" r:id="rId9"/>
-    <p:sldId id="273" r:id="rId10"/>
-    <p:sldId id="274" r:id="rId11"/>
+    <p:sldId id="276" r:id="rId6"/>
+    <p:sldId id="278" r:id="rId7"/>
+    <p:sldId id="263" r:id="rId8"/>
+    <p:sldId id="273" r:id="rId9"/>
+    <p:sldId id="274" r:id="rId10"/>
   </p:sldIdLst>
   <p:sldSz cx="18288000" cy="10287000"/>
   <p:notesSz cx="6858000" cy="9144000"/>
   <p:embeddedFontLst>
     <p:embeddedFont>
       <p:font typeface="Calibri" panose="020F0502020204030204" pitchFamily="34" charset="0"/>
-      <p:regular r:id="rId13"/>
-      <p:bold r:id="rId14"/>
-      <p:italic r:id="rId15"/>
-      <p:boldItalic r:id="rId16"/>
+      <p:regular r:id="rId12"/>
+      <p:bold r:id="rId13"/>
+      <p:italic r:id="rId14"/>
+      <p:boldItalic r:id="rId15"/>
     </p:embeddedFont>
     <p:embeddedFont>
-      <p:font typeface="Poppins" panose="020B0604020202020204" charset="0"/>
-      <p:regular r:id="rId17"/>
-      <p:bold r:id="rId18"/>
-      <p:italic r:id="rId19"/>
-      <p:boldItalic r:id="rId20"/>
+      <p:font typeface="Poppins" panose="020B0502040204020203" pitchFamily="2" charset="0"/>
+      <p:regular r:id="rId16"/>
+      <p:bold r:id="rId17"/>
+      <p:italic r:id="rId18"/>
+      <p:boldItalic r:id="rId19"/>
     </p:embeddedFont>
   </p:embeddedFontLst>
   <p:defaultTextStyle>
@@ -840,115 +839,6 @@
 </p:notes>
 </file>
 
-<file path=ppt/notesSlides/notesSlide10.xml><?xml version="1.0" encoding="utf-8"?>
-<p:notes xmlns:a="http://schemas.openxmlformats.org/drawingml/2006/main" xmlns:r="http://schemas.openxmlformats.org/officeDocument/2006/relationships" xmlns:p="http://schemas.openxmlformats.org/presentationml/2006/main" showMasterSp="0" showMasterPhAnim="0">
-  <p:cSld>
-    <p:spTree>
-      <p:nvGrpSpPr>
-        <p:cNvPr id="1" name="Shape 214"/>
-        <p:cNvGrpSpPr/>
-        <p:nvPr/>
-      </p:nvGrpSpPr>
-      <p:grpSpPr>
-        <a:xfrm>
-          <a:off x="0" y="0"/>
-          <a:ext cx="0" cy="0"/>
-          <a:chOff x="0" y="0"/>
-          <a:chExt cx="0" cy="0"/>
-        </a:xfrm>
-      </p:grpSpPr>
-      <p:sp>
-        <p:nvSpPr>
-          <p:cNvPr id="215" name="Google Shape;215;p13:notes"/>
-          <p:cNvSpPr txBox="1">
-            <a:spLocks noGrp="1"/>
-          </p:cNvSpPr>
-          <p:nvPr>
-            <p:ph type="body" idx="1"/>
-          </p:nvPr>
-        </p:nvSpPr>
-        <p:spPr>
-          <a:xfrm>
-            <a:off x="685800" y="4343400"/>
-            <a:ext cx="5486400" cy="4114800"/>
-          </a:xfrm>
-          <a:prstGeom prst="rect">
-            <a:avLst/>
-          </a:prstGeom>
-        </p:spPr>
-        <p:txBody>
-          <a:bodyPr spcFirstLastPara="1" wrap="square" lIns="91425" tIns="91425" rIns="91425" bIns="91425" anchor="t" anchorCtr="0">
-            <a:noAutofit/>
-          </a:bodyPr>
-          <a:lstStyle/>
-          <a:p>
-            <a:pPr marL="0" lvl="0" indent="0" algn="l" rtl="0">
-              <a:spcBef>
-                <a:spcPts val="0"/>
-              </a:spcBef>
-              <a:spcAft>
-                <a:spcPts val="0"/>
-              </a:spcAft>
-              <a:buNone/>
-            </a:pPr>
-            <a:endParaRPr/>
-          </a:p>
-        </p:txBody>
-      </p:sp>
-      <p:sp>
-        <p:nvSpPr>
-          <p:cNvPr id="216" name="Google Shape;216;p13:notes"/>
-          <p:cNvSpPr>
-            <a:spLocks noGrp="1" noRot="1" noChangeAspect="1"/>
-          </p:cNvSpPr>
-          <p:nvPr>
-            <p:ph type="sldImg" idx="2"/>
-          </p:nvPr>
-        </p:nvSpPr>
-        <p:spPr>
-          <a:xfrm>
-            <a:off x="381000" y="685800"/>
-            <a:ext cx="6096000" cy="3429000"/>
-          </a:xfrm>
-          <a:custGeom>
-            <a:avLst/>
-            <a:gdLst/>
-            <a:ahLst/>
-            <a:cxnLst/>
-            <a:rect l="l" t="t" r="r" b="b"/>
-            <a:pathLst>
-              <a:path w="120000" h="120000" extrusionOk="0">
-                <a:moveTo>
-                  <a:pt x="0" y="0"/>
-                </a:moveTo>
-                <a:lnTo>
-                  <a:pt x="120000" y="0"/>
-                </a:lnTo>
-                <a:lnTo>
-                  <a:pt x="120000" y="120000"/>
-                </a:lnTo>
-                <a:lnTo>
-                  <a:pt x="0" y="120000"/>
-                </a:lnTo>
-                <a:close/>
-              </a:path>
-            </a:pathLst>
-          </a:custGeom>
-        </p:spPr>
-      </p:sp>
-    </p:spTree>
-    <p:extLst>
-      <p:ext uri="{BB962C8B-B14F-4D97-AF65-F5344CB8AC3E}">
-        <p14:creationId xmlns:p14="http://schemas.microsoft.com/office/powerpoint/2010/main" val="933941784"/>
-      </p:ext>
-    </p:extLst>
-  </p:cSld>
-  <p:clrMapOvr>
-    <a:masterClrMapping/>
-  </p:clrMapOvr>
-</p:notes>
-</file>
-
 <file path=ppt/notesSlides/notesSlide2.xml><?xml version="1.0" encoding="utf-8"?>
 <p:notes xmlns:a="http://schemas.openxmlformats.org/drawingml/2006/main" xmlns:r="http://schemas.openxmlformats.org/officeDocument/2006/relationships" xmlns:p="http://schemas.openxmlformats.org/presentationml/2006/main" showMasterSp="0" showMasterPhAnim="0">
   <p:cSld>
@@ -1375,7 +1265,7 @@
     </p:spTree>
     <p:extLst>
       <p:ext uri="{BB962C8B-B14F-4D97-AF65-F5344CB8AC3E}">
-        <p14:creationId xmlns:p14="http://schemas.microsoft.com/office/powerpoint/2010/main" val="744504237"/>
+        <p14:creationId xmlns:p14="http://schemas.microsoft.com/office/powerpoint/2010/main" val="2793363355"/>
       </p:ext>
     </p:extLst>
   </p:cSld>
@@ -1386,115 +1276,6 @@
 </file>
 
 <file path=ppt/notesSlides/notesSlide6.xml><?xml version="1.0" encoding="utf-8"?>
-<p:notes xmlns:a="http://schemas.openxmlformats.org/drawingml/2006/main" xmlns:r="http://schemas.openxmlformats.org/officeDocument/2006/relationships" xmlns:p="http://schemas.openxmlformats.org/presentationml/2006/main" showMasterSp="0" showMasterPhAnim="0">
-  <p:cSld>
-    <p:spTree>
-      <p:nvGrpSpPr>
-        <p:cNvPr id="1" name="Shape 146"/>
-        <p:cNvGrpSpPr/>
-        <p:nvPr/>
-      </p:nvGrpSpPr>
-      <p:grpSpPr>
-        <a:xfrm>
-          <a:off x="0" y="0"/>
-          <a:ext cx="0" cy="0"/>
-          <a:chOff x="0" y="0"/>
-          <a:chExt cx="0" cy="0"/>
-        </a:xfrm>
-      </p:grpSpPr>
-      <p:sp>
-        <p:nvSpPr>
-          <p:cNvPr id="147" name="Google Shape;147;p7:notes"/>
-          <p:cNvSpPr txBox="1">
-            <a:spLocks noGrp="1"/>
-          </p:cNvSpPr>
-          <p:nvPr>
-            <p:ph type="body" idx="1"/>
-          </p:nvPr>
-        </p:nvSpPr>
-        <p:spPr>
-          <a:xfrm>
-            <a:off x="685800" y="4343400"/>
-            <a:ext cx="5486400" cy="4114800"/>
-          </a:xfrm>
-          <a:prstGeom prst="rect">
-            <a:avLst/>
-          </a:prstGeom>
-        </p:spPr>
-        <p:txBody>
-          <a:bodyPr spcFirstLastPara="1" wrap="square" lIns="91425" tIns="91425" rIns="91425" bIns="91425" anchor="t" anchorCtr="0">
-            <a:noAutofit/>
-          </a:bodyPr>
-          <a:lstStyle/>
-          <a:p>
-            <a:pPr marL="0" lvl="0" indent="0" algn="l" rtl="0">
-              <a:spcBef>
-                <a:spcPts val="0"/>
-              </a:spcBef>
-              <a:spcAft>
-                <a:spcPts val="0"/>
-              </a:spcAft>
-              <a:buNone/>
-            </a:pPr>
-            <a:endParaRPr/>
-          </a:p>
-        </p:txBody>
-      </p:sp>
-      <p:sp>
-        <p:nvSpPr>
-          <p:cNvPr id="148" name="Google Shape;148;p7:notes"/>
-          <p:cNvSpPr>
-            <a:spLocks noGrp="1" noRot="1" noChangeAspect="1"/>
-          </p:cNvSpPr>
-          <p:nvPr>
-            <p:ph type="sldImg" idx="2"/>
-          </p:nvPr>
-        </p:nvSpPr>
-        <p:spPr>
-          <a:xfrm>
-            <a:off x="381000" y="685800"/>
-            <a:ext cx="6096000" cy="3429000"/>
-          </a:xfrm>
-          <a:custGeom>
-            <a:avLst/>
-            <a:gdLst/>
-            <a:ahLst/>
-            <a:cxnLst/>
-            <a:rect l="l" t="t" r="r" b="b"/>
-            <a:pathLst>
-              <a:path w="120000" h="120000" extrusionOk="0">
-                <a:moveTo>
-                  <a:pt x="0" y="0"/>
-                </a:moveTo>
-                <a:lnTo>
-                  <a:pt x="120000" y="0"/>
-                </a:lnTo>
-                <a:lnTo>
-                  <a:pt x="120000" y="120000"/>
-                </a:lnTo>
-                <a:lnTo>
-                  <a:pt x="0" y="120000"/>
-                </a:lnTo>
-                <a:close/>
-              </a:path>
-            </a:pathLst>
-          </a:custGeom>
-        </p:spPr>
-      </p:sp>
-    </p:spTree>
-    <p:extLst>
-      <p:ext uri="{BB962C8B-B14F-4D97-AF65-F5344CB8AC3E}">
-        <p14:creationId xmlns:p14="http://schemas.microsoft.com/office/powerpoint/2010/main" val="2793363355"/>
-      </p:ext>
-    </p:extLst>
-  </p:cSld>
-  <p:clrMapOvr>
-    <a:masterClrMapping/>
-  </p:clrMapOvr>
-</p:notes>
-</file>
-
-<file path=ppt/notesSlides/notesSlide7.xml><?xml version="1.0" encoding="utf-8"?>
 <p:notes xmlns:a="http://schemas.openxmlformats.org/drawingml/2006/main" xmlns:r="http://schemas.openxmlformats.org/officeDocument/2006/relationships" xmlns:p="http://schemas.openxmlformats.org/presentationml/2006/main" showMasterSp="0" showMasterPhAnim="0">
   <p:cSld>
     <p:spTree>
@@ -1603,7 +1384,7 @@
 </p:notes>
 </file>
 
-<file path=ppt/notesSlides/notesSlide8.xml><?xml version="1.0" encoding="utf-8"?>
+<file path=ppt/notesSlides/notesSlide7.xml><?xml version="1.0" encoding="utf-8"?>
 <p:notes xmlns:a="http://schemas.openxmlformats.org/drawingml/2006/main" xmlns:r="http://schemas.openxmlformats.org/officeDocument/2006/relationships" xmlns:p="http://schemas.openxmlformats.org/presentationml/2006/main" showMasterSp="0" showMasterPhAnim="0">
   <p:cSld>
     <p:spTree>
@@ -1712,7 +1493,7 @@
 </p:notes>
 </file>
 
-<file path=ppt/notesSlides/notesSlide9.xml><?xml version="1.0" encoding="utf-8"?>
+<file path=ppt/notesSlides/notesSlide8.xml><?xml version="1.0" encoding="utf-8"?>
 <p:notes xmlns:a="http://schemas.openxmlformats.org/drawingml/2006/main" xmlns:r="http://schemas.openxmlformats.org/officeDocument/2006/relationships" xmlns:p="http://schemas.openxmlformats.org/presentationml/2006/main" showMasterSp="0" showMasterPhAnim="0">
   <p:cSld>
     <p:spTree>
@@ -1812,6 +1593,115 @@
     <p:extLst>
       <p:ext uri="{BB962C8B-B14F-4D97-AF65-F5344CB8AC3E}">
         <p14:creationId xmlns:p14="http://schemas.microsoft.com/office/powerpoint/2010/main" val="616603495"/>
+      </p:ext>
+    </p:extLst>
+  </p:cSld>
+  <p:clrMapOvr>
+    <a:masterClrMapping/>
+  </p:clrMapOvr>
+</p:notes>
+</file>
+
+<file path=ppt/notesSlides/notesSlide9.xml><?xml version="1.0" encoding="utf-8"?>
+<p:notes xmlns:a="http://schemas.openxmlformats.org/drawingml/2006/main" xmlns:r="http://schemas.openxmlformats.org/officeDocument/2006/relationships" xmlns:p="http://schemas.openxmlformats.org/presentationml/2006/main" showMasterSp="0" showMasterPhAnim="0">
+  <p:cSld>
+    <p:spTree>
+      <p:nvGrpSpPr>
+        <p:cNvPr id="1" name="Shape 214"/>
+        <p:cNvGrpSpPr/>
+        <p:nvPr/>
+      </p:nvGrpSpPr>
+      <p:grpSpPr>
+        <a:xfrm>
+          <a:off x="0" y="0"/>
+          <a:ext cx="0" cy="0"/>
+          <a:chOff x="0" y="0"/>
+          <a:chExt cx="0" cy="0"/>
+        </a:xfrm>
+      </p:grpSpPr>
+      <p:sp>
+        <p:nvSpPr>
+          <p:cNvPr id="215" name="Google Shape;215;p13:notes"/>
+          <p:cNvSpPr txBox="1">
+            <a:spLocks noGrp="1"/>
+          </p:cNvSpPr>
+          <p:nvPr>
+            <p:ph type="body" idx="1"/>
+          </p:nvPr>
+        </p:nvSpPr>
+        <p:spPr>
+          <a:xfrm>
+            <a:off x="685800" y="4343400"/>
+            <a:ext cx="5486400" cy="4114800"/>
+          </a:xfrm>
+          <a:prstGeom prst="rect">
+            <a:avLst/>
+          </a:prstGeom>
+        </p:spPr>
+        <p:txBody>
+          <a:bodyPr spcFirstLastPara="1" wrap="square" lIns="91425" tIns="91425" rIns="91425" bIns="91425" anchor="t" anchorCtr="0">
+            <a:noAutofit/>
+          </a:bodyPr>
+          <a:lstStyle/>
+          <a:p>
+            <a:pPr marL="0" lvl="0" indent="0" algn="l" rtl="0">
+              <a:spcBef>
+                <a:spcPts val="0"/>
+              </a:spcBef>
+              <a:spcAft>
+                <a:spcPts val="0"/>
+              </a:spcAft>
+              <a:buNone/>
+            </a:pPr>
+            <a:endParaRPr/>
+          </a:p>
+        </p:txBody>
+      </p:sp>
+      <p:sp>
+        <p:nvSpPr>
+          <p:cNvPr id="216" name="Google Shape;216;p13:notes"/>
+          <p:cNvSpPr>
+            <a:spLocks noGrp="1" noRot="1" noChangeAspect="1"/>
+          </p:cNvSpPr>
+          <p:nvPr>
+            <p:ph type="sldImg" idx="2"/>
+          </p:nvPr>
+        </p:nvSpPr>
+        <p:spPr>
+          <a:xfrm>
+            <a:off x="381000" y="685800"/>
+            <a:ext cx="6096000" cy="3429000"/>
+          </a:xfrm>
+          <a:custGeom>
+            <a:avLst/>
+            <a:gdLst/>
+            <a:ahLst/>
+            <a:cxnLst/>
+            <a:rect l="l" t="t" r="r" b="b"/>
+            <a:pathLst>
+              <a:path w="120000" h="120000" extrusionOk="0">
+                <a:moveTo>
+                  <a:pt x="0" y="0"/>
+                </a:moveTo>
+                <a:lnTo>
+                  <a:pt x="120000" y="0"/>
+                </a:lnTo>
+                <a:lnTo>
+                  <a:pt x="120000" y="120000"/>
+                </a:lnTo>
+                <a:lnTo>
+                  <a:pt x="0" y="120000"/>
+                </a:lnTo>
+                <a:close/>
+              </a:path>
+            </a:pathLst>
+          </a:custGeom>
+        </p:spPr>
+      </p:sp>
+    </p:spTree>
+    <p:extLst>
+      <p:ext uri="{BB962C8B-B14F-4D97-AF65-F5344CB8AC3E}">
+        <p14:creationId xmlns:p14="http://schemas.microsoft.com/office/powerpoint/2010/main" val="933941784"/>
       </p:ext>
     </p:extLst>
   </p:cSld>
@@ -7689,228 +7579,6 @@
 </p:sld>
 </file>
 
-<file path=ppt/slides/slide10.xml><?xml version="1.0" encoding="utf-8"?>
-<p:sld xmlns:a="http://schemas.openxmlformats.org/drawingml/2006/main" xmlns:r="http://schemas.openxmlformats.org/officeDocument/2006/relationships" xmlns:p="http://schemas.openxmlformats.org/presentationml/2006/main">
-  <p:cSld>
-    <p:spTree>
-      <p:nvGrpSpPr>
-        <p:cNvPr id="1" name="Shape 217"/>
-        <p:cNvGrpSpPr/>
-        <p:nvPr/>
-      </p:nvGrpSpPr>
-      <p:grpSpPr>
-        <a:xfrm>
-          <a:off x="0" y="0"/>
-          <a:ext cx="0" cy="0"/>
-          <a:chOff x="0" y="0"/>
-          <a:chExt cx="0" cy="0"/>
-        </a:xfrm>
-      </p:grpSpPr>
-      <p:sp>
-        <p:nvSpPr>
-          <p:cNvPr id="218" name="Google Shape;218;p25"/>
-          <p:cNvSpPr/>
-          <p:nvPr/>
-        </p:nvSpPr>
-        <p:spPr>
-          <a:xfrm>
-            <a:off x="0" y="-103451"/>
-            <a:ext cx="8529633" cy="10493903"/>
-          </a:xfrm>
-          <a:prstGeom prst="rect">
-            <a:avLst/>
-          </a:prstGeom>
-          <a:gradFill>
-            <a:gsLst>
-              <a:gs pos="0">
-                <a:srgbClr val="14C5C3"/>
-              </a:gs>
-              <a:gs pos="100000">
-                <a:srgbClr val="4E7AD9"/>
-              </a:gs>
-            </a:gsLst>
-            <a:lin ang="2700000" scaled="0"/>
-          </a:gradFill>
-          <a:ln>
-            <a:noFill/>
-          </a:ln>
-        </p:spPr>
-        <p:txBody>
-          <a:bodyPr spcFirstLastPara="1" wrap="square" lIns="91425" tIns="91425" rIns="91425" bIns="91425" anchor="ctr" anchorCtr="0">
-            <a:noAutofit/>
-          </a:bodyPr>
-          <a:lstStyle/>
-          <a:p>
-            <a:pPr marL="0" lvl="0" indent="0" algn="l" rtl="0">
-              <a:spcBef>
-                <a:spcPts val="0"/>
-              </a:spcBef>
-              <a:spcAft>
-                <a:spcPts val="0"/>
-              </a:spcAft>
-              <a:buNone/>
-            </a:pPr>
-            <a:endParaRPr/>
-          </a:p>
-        </p:txBody>
-      </p:sp>
-      <p:sp>
-        <p:nvSpPr>
-          <p:cNvPr id="221" name="Google Shape;221;p25"/>
-          <p:cNvSpPr txBox="1"/>
-          <p:nvPr/>
-        </p:nvSpPr>
-        <p:spPr>
-          <a:xfrm>
-            <a:off x="8749553" y="1884979"/>
-            <a:ext cx="9538447" cy="3570208"/>
-          </a:xfrm>
-          <a:prstGeom prst="rect">
-            <a:avLst/>
-          </a:prstGeom>
-          <a:noFill/>
-          <a:ln>
-            <a:noFill/>
-          </a:ln>
-        </p:spPr>
-        <p:txBody>
-          <a:bodyPr spcFirstLastPara="1" wrap="square" lIns="0" tIns="0" rIns="0" bIns="0" anchor="t" anchorCtr="0">
-            <a:spAutoFit/>
-          </a:bodyPr>
-          <a:lstStyle/>
-          <a:p>
-            <a:r>
-              <a:rPr lang="es-ES" sz="4800" dirty="0"/>
-              <a:t>Si todo esto que te he dicho te parece interesante te invito que seas parte de esta investigación</a:t>
-            </a:r>
-          </a:p>
-          <a:p>
-            <a:endParaRPr lang="es-ES" sz="2800" dirty="0"/>
-          </a:p>
-          <a:p>
-            <a:r>
-              <a:rPr lang="es-ES" sz="6000" dirty="0" err="1">
-                <a:solidFill>
-                  <a:srgbClr val="0070C0"/>
-                </a:solidFill>
-              </a:rPr>
-              <a:t>MoreCoasts</a:t>
-            </a:r>
-            <a:r>
-              <a:rPr lang="es-ES" sz="6000">
-                <a:solidFill>
-                  <a:srgbClr val="0070C0"/>
-                </a:solidFill>
-              </a:rPr>
-              <a:t> cuida </a:t>
-            </a:r>
-            <a:r>
-              <a:rPr lang="es-ES" sz="6000" dirty="0">
-                <a:solidFill>
-                  <a:srgbClr val="0070C0"/>
-                </a:solidFill>
-              </a:rPr>
-              <a:t>tu playa</a:t>
-            </a:r>
-          </a:p>
-        </p:txBody>
-      </p:sp>
-      <p:pic>
-        <p:nvPicPr>
-          <p:cNvPr id="6" name="Imagen 5"/>
-          <p:cNvPicPr>
-            <a:picLocks noChangeAspect="1"/>
-          </p:cNvPicPr>
-          <p:nvPr/>
-        </p:nvPicPr>
-        <p:blipFill>
-          <a:blip r:embed="rId3" cstate="print">
-            <a:extLst>
-              <a:ext uri="{28A0092B-C50C-407E-A947-70E740481C1C}">
-                <a14:useLocalDpi xmlns:a14="http://schemas.microsoft.com/office/drawing/2010/main" val="0"/>
-              </a:ext>
-            </a:extLst>
-          </a:blip>
-          <a:stretch>
-            <a:fillRect/>
-          </a:stretch>
-        </p:blipFill>
-        <p:spPr>
-          <a:xfrm>
-            <a:off x="914400" y="4207475"/>
-            <a:ext cx="1834307" cy="1872050"/>
-          </a:xfrm>
-          <a:prstGeom prst="rect">
-            <a:avLst/>
-          </a:prstGeom>
-        </p:spPr>
-      </p:pic>
-      <p:sp>
-        <p:nvSpPr>
-          <p:cNvPr id="7" name="Google Shape;88;p13"/>
-          <p:cNvSpPr txBox="1"/>
-          <p:nvPr/>
-        </p:nvSpPr>
-        <p:spPr>
-          <a:xfrm>
-            <a:off x="-2320422" y="4681835"/>
-            <a:ext cx="9712800" cy="923330"/>
-          </a:xfrm>
-          <a:prstGeom prst="rect">
-            <a:avLst/>
-          </a:prstGeom>
-          <a:noFill/>
-          <a:ln>
-            <a:noFill/>
-          </a:ln>
-        </p:spPr>
-        <p:txBody>
-          <a:bodyPr spcFirstLastPara="1" wrap="square" lIns="0" tIns="0" rIns="0" bIns="0" anchor="t" anchorCtr="0">
-            <a:spAutoFit/>
-          </a:bodyPr>
-          <a:lstStyle/>
-          <a:p>
-            <a:pPr marL="0" marR="0" lvl="0" indent="0" algn="r" rtl="0">
-              <a:lnSpc>
-                <a:spcPct val="100000"/>
-              </a:lnSpc>
-              <a:spcBef>
-                <a:spcPts val="0"/>
-              </a:spcBef>
-              <a:spcAft>
-                <a:spcPts val="0"/>
-              </a:spcAft>
-              <a:buNone/>
-            </a:pPr>
-            <a:r>
-              <a:rPr lang="es-ES" sz="6000" b="1" i="0" u="none" strike="noStrike" cap="none" dirty="0" err="1">
-                <a:solidFill>
-                  <a:srgbClr val="FFFFFF"/>
-                </a:solidFill>
-                <a:latin typeface="Poppins"/>
-                <a:ea typeface="Poppins"/>
-                <a:cs typeface="Poppins"/>
-                <a:sym typeface="Poppins"/>
-              </a:rPr>
-              <a:t>MoreCoast</a:t>
-            </a:r>
-            <a:endParaRPr sz="800" dirty="0"/>
-          </a:p>
-        </p:txBody>
-      </p:sp>
-    </p:spTree>
-    <p:extLst>
-      <p:ext uri="{BB962C8B-B14F-4D97-AF65-F5344CB8AC3E}">
-        <p14:creationId xmlns:p14="http://schemas.microsoft.com/office/powerpoint/2010/main" val="3689913601"/>
-      </p:ext>
-    </p:extLst>
-  </p:cSld>
-  <p:clrMapOvr>
-    <a:masterClrMapping/>
-  </p:clrMapOvr>
-</p:sld>
-</file>
-
 <file path=ppt/slides/slide2.xml><?xml version="1.0" encoding="utf-8"?>
 <p:sld xmlns:a="http://schemas.openxmlformats.org/drawingml/2006/main" xmlns:r="http://schemas.openxmlformats.org/officeDocument/2006/relationships" xmlns:p="http://schemas.openxmlformats.org/presentationml/2006/main">
   <p:cSld>
@@ -8695,7 +8363,7 @@
         </p:nvSpPr>
         <p:spPr>
           <a:xfrm>
-            <a:off x="10617674" y="1028700"/>
+            <a:off x="5463783" y="0"/>
             <a:ext cx="7670326" cy="2424691"/>
           </a:xfrm>
           <a:prstGeom prst="rect">
@@ -8743,8 +8411,8 @@
         </p:nvSpPr>
         <p:spPr>
           <a:xfrm>
-            <a:off x="11499833" y="1633034"/>
-            <a:ext cx="5906009" cy="1354089"/>
+            <a:off x="5904862" y="535300"/>
+            <a:ext cx="6788168" cy="1354089"/>
           </a:xfrm>
           <a:prstGeom prst="rect">
             <a:avLst/>
@@ -8773,7 +8441,7 @@
               <a:buNone/>
             </a:pPr>
             <a:r>
-              <a:rPr lang="en-US" sz="7999" b="1" i="0" u="none" strike="noStrike" cap="none" dirty="0">
+              <a:rPr lang="en-US" sz="7999" b="1" i="0" u="none" strike="noStrike" cap="none" dirty="0" err="1">
                 <a:solidFill>
                   <a:srgbClr val="FFFFFF"/>
                 </a:solidFill>
@@ -8782,7 +8450,7 @@
                 <a:cs typeface="Poppins"/>
                 <a:sym typeface="Poppins"/>
               </a:rPr>
-              <a:t>Solución</a:t>
+              <a:t>Resultados</a:t>
             </a:r>
             <a:endParaRPr dirty="0"/>
           </a:p>
@@ -8796,8 +8464,8 @@
         </p:nvSpPr>
         <p:spPr>
           <a:xfrm>
-            <a:off x="10861530" y="3901935"/>
-            <a:ext cx="7182614" cy="4431983"/>
+            <a:off x="1243227" y="2420624"/>
+            <a:ext cx="16712263" cy="2462213"/>
           </a:xfrm>
           <a:prstGeom prst="rect">
             <a:avLst/>
@@ -8813,47 +8481,62 @@
           </a:bodyPr>
           <a:lstStyle/>
           <a:p>
+            <a:pPr marL="571500" indent="-571500">
+              <a:buFontTx/>
+              <a:buChar char="-"/>
+            </a:pPr>
             <a:r>
-              <a:rPr lang="es-ES" sz="4800" dirty="0"/>
-              <a:t>Para ello hemos desarrollado una aplicación de escritorio que permite calcular, almacenar y buscar datos de forma efectiva. </a:t>
+              <a:rPr lang="es-ES" sz="4000" dirty="0"/>
+              <a:t>Modelación de las interfaces y presentación al cliente</a:t>
             </a:r>
+          </a:p>
+          <a:p>
+            <a:pPr marL="685800" indent="-685800">
+              <a:buFontTx/>
+              <a:buChar char="-"/>
+            </a:pPr>
+            <a:r>
+              <a:rPr lang="es-ES" sz="4000" dirty="0"/>
+              <a:t>Desarrollo del </a:t>
+            </a:r>
+            <a:r>
+              <a:rPr lang="es-ES" sz="4000" dirty="0" err="1"/>
+              <a:t>backend</a:t>
+            </a:r>
+            <a:r>
+              <a:rPr lang="es-ES" sz="4000" dirty="0"/>
+              <a:t> y su compatibilidad con la plantilla</a:t>
+            </a:r>
+          </a:p>
+          <a:p>
+            <a:pPr marL="685800" indent="-685800">
+              <a:buFontTx/>
+              <a:buChar char="-"/>
+            </a:pPr>
+            <a:r>
+              <a:rPr lang="es-ES" sz="4000" dirty="0"/>
+              <a:t>Dominio de la plantilla y sus componentes</a:t>
+            </a:r>
+          </a:p>
+          <a:p>
+            <a:pPr marL="685800" indent="-685800">
+              <a:buFontTx/>
+              <a:buChar char="-"/>
+            </a:pPr>
+            <a:r>
+              <a:rPr lang="es-ES" sz="4000" dirty="0"/>
+              <a:t>Se a desarrollado la historia de usuario a un 50% </a:t>
+            </a:r>
+            <a:endParaRPr lang="es-ES" sz="4800" dirty="0"/>
           </a:p>
         </p:txBody>
       </p:sp>
-      <p:pic>
-        <p:nvPicPr>
-          <p:cNvPr id="11" name="Imagen 10"/>
-          <p:cNvPicPr/>
-          <p:nvPr/>
-        </p:nvPicPr>
-        <p:blipFill>
-          <a:blip r:embed="rId3" cstate="print">
-            <a:extLst>
-              <a:ext uri="{28A0092B-C50C-407E-A947-70E740481C1C}">
-                <a14:useLocalDpi xmlns:a14="http://schemas.microsoft.com/office/drawing/2010/main" val="0"/>
-              </a:ext>
-            </a:extLst>
-          </a:blip>
-          <a:srcRect/>
-          <a:stretch>
-            <a:fillRect/>
-          </a:stretch>
-        </p:blipFill>
-        <p:spPr bwMode="auto">
-          <a:xfrm>
-            <a:off x="143436" y="1633034"/>
-            <a:ext cx="10273553" cy="6560412"/>
-          </a:xfrm>
-          <a:prstGeom prst="rect">
-            <a:avLst/>
-          </a:prstGeom>
-          <a:noFill/>
-          <a:ln>
-            <a:noFill/>
-          </a:ln>
-        </p:spPr>
-      </p:pic>
     </p:spTree>
+    <p:extLst>
+      <p:ext uri="{BB962C8B-B14F-4D97-AF65-F5344CB8AC3E}">
+        <p14:creationId xmlns:p14="http://schemas.microsoft.com/office/powerpoint/2010/main" val="1544977281"/>
+      </p:ext>
+    </p:extLst>
   </p:cSld>
   <p:clrMapOvr>
     <a:masterClrMapping/>
@@ -8934,276 +8617,6 @@
         </p:nvSpPr>
         <p:spPr>
           <a:xfrm>
-            <a:off x="5463783" y="0"/>
-            <a:ext cx="7670326" cy="2424691"/>
-          </a:xfrm>
-          <a:prstGeom prst="rect">
-            <a:avLst/>
-          </a:prstGeom>
-          <a:gradFill>
-            <a:gsLst>
-              <a:gs pos="0">
-                <a:srgbClr val="14C5C3"/>
-              </a:gs>
-              <a:gs pos="100000">
-                <a:srgbClr val="4E7AD9"/>
-              </a:gs>
-            </a:gsLst>
-            <a:lin ang="2700000" scaled="0"/>
-          </a:gradFill>
-          <a:ln>
-            <a:noFill/>
-          </a:ln>
-        </p:spPr>
-        <p:txBody>
-          <a:bodyPr spcFirstLastPara="1" wrap="square" lIns="91425" tIns="91425" rIns="91425" bIns="91425" anchor="ctr" anchorCtr="0">
-            <a:noAutofit/>
-          </a:bodyPr>
-          <a:lstStyle/>
-          <a:p>
-            <a:pPr marL="0" lvl="0" indent="0" algn="l" rtl="0">
-              <a:spcBef>
-                <a:spcPts val="0"/>
-              </a:spcBef>
-              <a:spcAft>
-                <a:spcPts val="0"/>
-              </a:spcAft>
-              <a:buNone/>
-            </a:pPr>
-            <a:endParaRPr/>
-          </a:p>
-        </p:txBody>
-      </p:sp>
-      <p:sp>
-        <p:nvSpPr>
-          <p:cNvPr id="152" name="Google Shape;152;p19"/>
-          <p:cNvSpPr txBox="1"/>
-          <p:nvPr/>
-        </p:nvSpPr>
-        <p:spPr>
-          <a:xfrm>
-            <a:off x="5904862" y="535300"/>
-            <a:ext cx="6788168" cy="1354089"/>
-          </a:xfrm>
-          <a:prstGeom prst="rect">
-            <a:avLst/>
-          </a:prstGeom>
-          <a:noFill/>
-          <a:ln>
-            <a:noFill/>
-          </a:ln>
-        </p:spPr>
-        <p:txBody>
-          <a:bodyPr spcFirstLastPara="1" wrap="square" lIns="0" tIns="0" rIns="0" bIns="0" anchor="t" anchorCtr="0">
-            <a:spAutoFit/>
-          </a:bodyPr>
-          <a:lstStyle/>
-          <a:p>
-            <a:pPr marL="0" marR="0" lvl="0" indent="0" algn="ctr" rtl="0">
-              <a:lnSpc>
-                <a:spcPct val="110001"/>
-              </a:lnSpc>
-              <a:spcBef>
-                <a:spcPts val="0"/>
-              </a:spcBef>
-              <a:spcAft>
-                <a:spcPts val="0"/>
-              </a:spcAft>
-              <a:buNone/>
-            </a:pPr>
-            <a:r>
-              <a:rPr lang="en-US" sz="7999" b="1" i="0" u="none" strike="noStrike" cap="none" dirty="0" err="1">
-                <a:solidFill>
-                  <a:srgbClr val="FFFFFF"/>
-                </a:solidFill>
-                <a:latin typeface="Poppins"/>
-                <a:ea typeface="Poppins"/>
-                <a:cs typeface="Poppins"/>
-                <a:sym typeface="Poppins"/>
-              </a:rPr>
-              <a:t>Resultados</a:t>
-            </a:r>
-            <a:endParaRPr dirty="0"/>
-          </a:p>
-        </p:txBody>
-      </p:sp>
-      <p:sp>
-        <p:nvSpPr>
-          <p:cNvPr id="153" name="Google Shape;153;p19"/>
-          <p:cNvSpPr txBox="1"/>
-          <p:nvPr/>
-        </p:nvSpPr>
-        <p:spPr>
-          <a:xfrm>
-            <a:off x="1243227" y="2420624"/>
-            <a:ext cx="16712263" cy="8125301"/>
-          </a:xfrm>
-          <a:prstGeom prst="rect">
-            <a:avLst/>
-          </a:prstGeom>
-          <a:noFill/>
-          <a:ln>
-            <a:noFill/>
-          </a:ln>
-        </p:spPr>
-        <p:txBody>
-          <a:bodyPr spcFirstLastPara="1" wrap="square" lIns="0" tIns="0" rIns="0" bIns="0" anchor="t" anchorCtr="0">
-            <a:spAutoFit/>
-          </a:bodyPr>
-          <a:lstStyle/>
-          <a:p>
-            <a:r>
-              <a:rPr lang="es-ES" sz="4000" dirty="0"/>
-              <a:t>-Desarrollo de la tesis desde la introducción hasta el capítulo 1. Venciendo el estado del arte, herramientas y lenguajes, metodología empleada y arquitectura de microservicio.</a:t>
-            </a:r>
-          </a:p>
-          <a:p>
-            <a:pPr marL="685800" indent="-685800">
-              <a:buFontTx/>
-              <a:buChar char="-"/>
-            </a:pPr>
-            <a:r>
-              <a:rPr lang="es-ES" sz="4000" dirty="0"/>
-              <a:t>En cuanto a la aplicación web he aprendido a usar los </a:t>
-            </a:r>
-            <a:r>
-              <a:rPr lang="es-ES" sz="4000" dirty="0" err="1"/>
-              <a:t>useState</a:t>
-            </a:r>
-            <a:r>
-              <a:rPr lang="es-ES" sz="4000" dirty="0"/>
-              <a:t> para obtener los datos de los inputs.</a:t>
-            </a:r>
-          </a:p>
-          <a:p>
-            <a:pPr marL="685800" indent="-685800">
-              <a:buFontTx/>
-              <a:buChar char="-"/>
-            </a:pPr>
-            <a:r>
-              <a:rPr lang="es-ES" sz="4000" dirty="0"/>
-              <a:t>Desarrolle las consultas de crear, eliminar editar en la base datos comprobando por consola que compilaba y se visualizan los cambios en Mongo Compass</a:t>
-            </a:r>
-          </a:p>
-          <a:p>
-            <a:pPr marL="685800" indent="-685800">
-              <a:buFontTx/>
-              <a:buChar char="-"/>
-            </a:pPr>
-            <a:r>
-              <a:rPr lang="es-ES" sz="4000" dirty="0"/>
-              <a:t>Desarrolle los prototipos de interfaces</a:t>
-            </a:r>
-          </a:p>
-          <a:p>
-            <a:pPr marL="685800" indent="-685800">
-              <a:buFontTx/>
-              <a:buChar char="-"/>
-            </a:pPr>
-            <a:r>
-              <a:rPr lang="es-ES" sz="4000" dirty="0"/>
-              <a:t>Inicie la codificación de una de las historias de usuario(Cálculo), los datos entrados pueden ser calculados y se muestra con </a:t>
-            </a:r>
-            <a:r>
-              <a:rPr lang="es-ES" sz="4000" dirty="0" err="1"/>
-              <a:t>alert</a:t>
-            </a:r>
-            <a:r>
-              <a:rPr lang="es-ES" sz="4000" dirty="0"/>
-              <a:t> (Inicialmente)</a:t>
-            </a:r>
-          </a:p>
-          <a:p>
-            <a:endParaRPr lang="es-ES" sz="4800" dirty="0"/>
-          </a:p>
-        </p:txBody>
-      </p:sp>
-    </p:spTree>
-    <p:extLst>
-      <p:ext uri="{BB962C8B-B14F-4D97-AF65-F5344CB8AC3E}">
-        <p14:creationId xmlns:p14="http://schemas.microsoft.com/office/powerpoint/2010/main" val="1544977281"/>
-      </p:ext>
-    </p:extLst>
-  </p:cSld>
-  <p:clrMapOvr>
-    <a:masterClrMapping/>
-  </p:clrMapOvr>
-</p:sld>
-</file>
-
-<file path=ppt/slides/slide7.xml><?xml version="1.0" encoding="utf-8"?>
-<p:sld xmlns:a="http://schemas.openxmlformats.org/drawingml/2006/main" xmlns:r="http://schemas.openxmlformats.org/officeDocument/2006/relationships" xmlns:p="http://schemas.openxmlformats.org/presentationml/2006/main">
-  <p:cSld>
-    <p:spTree>
-      <p:nvGrpSpPr>
-        <p:cNvPr id="1" name="Shape 149"/>
-        <p:cNvGrpSpPr/>
-        <p:nvPr/>
-      </p:nvGrpSpPr>
-      <p:grpSpPr>
-        <a:xfrm>
-          <a:off x="0" y="0"/>
-          <a:ext cx="0" cy="0"/>
-          <a:chOff x="0" y="0"/>
-          <a:chExt cx="0" cy="0"/>
-        </a:xfrm>
-      </p:grpSpPr>
-      <p:sp>
-        <p:nvSpPr>
-          <p:cNvPr id="150" name="Google Shape;150;p19"/>
-          <p:cNvSpPr/>
-          <p:nvPr/>
-        </p:nvSpPr>
-        <p:spPr>
-          <a:xfrm>
-            <a:off x="0" y="0"/>
-            <a:ext cx="1028700" cy="10287000"/>
-          </a:xfrm>
-          <a:prstGeom prst="rect">
-            <a:avLst/>
-          </a:prstGeom>
-          <a:gradFill>
-            <a:gsLst>
-              <a:gs pos="0">
-                <a:srgbClr val="14C5C3"/>
-              </a:gs>
-              <a:gs pos="100000">
-                <a:srgbClr val="4E7AD9"/>
-              </a:gs>
-            </a:gsLst>
-            <a:lin ang="2700000" scaled="0"/>
-          </a:gradFill>
-          <a:ln>
-            <a:noFill/>
-          </a:ln>
-        </p:spPr>
-        <p:txBody>
-          <a:bodyPr spcFirstLastPara="1" wrap="square" lIns="91425" tIns="91425" rIns="91425" bIns="91425" anchor="ctr" anchorCtr="0">
-            <a:noAutofit/>
-          </a:bodyPr>
-          <a:lstStyle/>
-          <a:p>
-            <a:pPr marL="0" lvl="0" indent="0" algn="l" rtl="0">
-              <a:spcBef>
-                <a:spcPts val="0"/>
-              </a:spcBef>
-              <a:spcAft>
-                <a:spcPts val="0"/>
-              </a:spcAft>
-              <a:buNone/>
-            </a:pPr>
-            <a:endParaRPr/>
-          </a:p>
-        </p:txBody>
-      </p:sp>
-      <p:sp>
-        <p:nvSpPr>
-          <p:cNvPr id="151" name="Google Shape;151;p19"/>
-          <p:cNvSpPr/>
-          <p:nvPr/>
-        </p:nvSpPr>
-        <p:spPr>
-          <a:xfrm>
             <a:off x="2057400" y="0"/>
             <a:ext cx="15524018" cy="2424691"/>
           </a:xfrm>
@@ -9252,7 +8665,7 @@
         </p:nvSpPr>
         <p:spPr>
           <a:xfrm>
-            <a:off x="2524991" y="533268"/>
+            <a:off x="2524991" y="535300"/>
             <a:ext cx="14588836" cy="1354089"/>
           </a:xfrm>
           <a:prstGeom prst="rect">
@@ -9269,30 +8682,11 @@
           </a:bodyPr>
           <a:lstStyle/>
           <a:p>
-            <a:pPr marL="0" marR="0" lvl="0" indent="0" algn="ctr" rtl="0">
+            <a:pPr lvl="0" algn="ctr">
               <a:lnSpc>
                 <a:spcPct val="110001"/>
               </a:lnSpc>
-              <a:spcBef>
-                <a:spcPts val="0"/>
-              </a:spcBef>
-              <a:spcAft>
-                <a:spcPts val="0"/>
-              </a:spcAft>
-              <a:buNone/>
             </a:pPr>
-            <a:r>
-              <a:rPr lang="en-US" sz="7999" b="1" i="0" u="none" strike="noStrike" cap="none" dirty="0" err="1">
-                <a:solidFill>
-                  <a:srgbClr val="FFFFFF"/>
-                </a:solidFill>
-                <a:latin typeface="Poppins"/>
-                <a:ea typeface="Poppins"/>
-                <a:cs typeface="Poppins"/>
-                <a:sym typeface="Poppins"/>
-              </a:rPr>
-              <a:t>Problemas</a:t>
-            </a:r>
             <a:r>
               <a:rPr lang="en-US" sz="7999" b="1" i="0" u="none" strike="noStrike" cap="none" dirty="0">
                 <a:solidFill>
@@ -9303,7 +8697,7 @@
                 <a:cs typeface="Poppins"/>
                 <a:sym typeface="Poppins"/>
               </a:rPr>
-              <a:t> y </a:t>
+              <a:t>Plan de </a:t>
             </a:r>
             <a:r>
               <a:rPr lang="en-US" sz="7999" b="1" i="0" u="none" strike="noStrike" cap="none" dirty="0" err="1">
@@ -9315,18 +8709,18 @@
                 <a:cs typeface="Poppins"/>
                 <a:sym typeface="Poppins"/>
               </a:rPr>
-              <a:t>Dificultades</a:t>
+              <a:t>Tareas</a:t>
             </a:r>
-            <a:endParaRPr dirty="0"/>
+            <a:endParaRPr lang="en-US" dirty="0"/>
           </a:p>
         </p:txBody>
       </p:sp>
       <p:sp>
         <p:nvSpPr>
-          <p:cNvPr id="6" name="CuadroTexto 5">
+          <p:cNvPr id="7" name="CuadroTexto 6">
             <a:extLst>
               <a:ext uri="{FF2B5EF4-FFF2-40B4-BE49-F238E27FC236}">
-                <a16:creationId xmlns:a16="http://schemas.microsoft.com/office/drawing/2014/main" id="{E5EC443C-5EB2-4D88-8DEB-673A9F86EDE2}"/>
+                <a16:creationId xmlns:a16="http://schemas.microsoft.com/office/drawing/2014/main" id="{C1159779-AFDD-4671-88BD-A628DC900C30}"/>
               </a:ext>
             </a:extLst>
           </p:cNvPr>
@@ -9335,8 +8729,8 @@
         </p:nvSpPr>
         <p:spPr>
           <a:xfrm>
-            <a:off x="1028700" y="2420625"/>
-            <a:ext cx="17259299" cy="8710077"/>
+            <a:off x="1205345" y="2635121"/>
+            <a:ext cx="16376073" cy="3785652"/>
           </a:xfrm>
           <a:prstGeom prst="rect">
             <a:avLst/>
@@ -9351,15 +8745,7 @@
           <a:p>
             <a:r>
               <a:rPr lang="es-ES" sz="4000" dirty="0"/>
-              <a:t>- </a:t>
-            </a:r>
-            <a:r>
-              <a:rPr lang="es-ES" sz="4000" dirty="0" err="1"/>
-              <a:t>React</a:t>
-            </a:r>
-            <a:r>
-              <a:rPr lang="es-ES" sz="4000" dirty="0"/>
-              <a:t> tiene una Curva de Aprendizaje Alto</a:t>
+              <a:t>Orden de las Acciones y Prioridades:</a:t>
             </a:r>
           </a:p>
           <a:p>
@@ -9369,67 +8755,52 @@
             </a:pPr>
             <a:r>
               <a:rPr lang="es-ES" sz="4000" dirty="0"/>
-              <a:t>Necesito saber los roles de como se comporta el flujo de trabajo:</a:t>
+              <a:t>Desarrollar la Historia De Usuario: Calculo</a:t>
             </a:r>
           </a:p>
           <a:p>
             <a:pPr marL="571500" indent="-571500">
-              <a:buFont typeface="Wingdings" panose="05000000000000000000" pitchFamily="2" charset="2"/>
-              <a:buChar char="Ø"/>
+              <a:buFontTx/>
+              <a:buChar char="-"/>
             </a:pPr>
             <a:r>
               <a:rPr lang="es-ES" sz="4000" dirty="0"/>
-              <a:t>Quién hace los cálculos</a:t>
+              <a:t>Desarrollar la Historia de Usuario: Usuarios</a:t>
             </a:r>
           </a:p>
           <a:p>
             <a:pPr marL="571500" indent="-571500">
-              <a:buFont typeface="Wingdings" panose="05000000000000000000" pitchFamily="2" charset="2"/>
-              <a:buChar char="Ø"/>
+              <a:buFontTx/>
+              <a:buChar char="-"/>
             </a:pPr>
             <a:r>
               <a:rPr lang="es-ES" sz="4000" dirty="0"/>
-              <a:t>Quién controla los cálculos o el trabajo realizado</a:t>
+              <a:t>Desarrollar la Historia de Usuario: Inicio y las Trazas del Sistema</a:t>
             </a:r>
           </a:p>
           <a:p>
             <a:pPr marL="571500" indent="-571500">
-              <a:buFont typeface="Wingdings" panose="05000000000000000000" pitchFamily="2" charset="2"/>
-              <a:buChar char="Ø"/>
+              <a:buFontTx/>
+              <a:buChar char="-"/>
             </a:pPr>
             <a:r>
               <a:rPr lang="es-ES" sz="4000" dirty="0"/>
-              <a:t>Cómo se recogen los datos en el terreno</a:t>
+              <a:t>Desarrollar la </a:t>
+            </a:r>
+            <a:r>
+              <a:rPr lang="es-ES" sz="4000" dirty="0" err="1"/>
+              <a:t>Busqueda</a:t>
+            </a:r>
+            <a:r>
+              <a:rPr lang="es-ES" sz="4000" dirty="0"/>
+              <a:t> Avanzada y las Salvas</a:t>
             </a:r>
           </a:p>
           <a:p>
-            <a:r>
-              <a:rPr lang="es-ES" sz="4000" dirty="0"/>
-              <a:t>-Cómo son los modelos donde se recogen los cálculos</a:t>
-            </a:r>
-          </a:p>
-          <a:p>
-            <a:r>
-              <a:rPr lang="es-ES" sz="4000" dirty="0"/>
-              <a:t>-No me queda claro aún como se refleja en la base de datos las alturas y los ángulos</a:t>
-            </a:r>
-          </a:p>
-          <a:p>
-            <a:r>
-              <a:rPr lang="es-ES" sz="4000" dirty="0"/>
-              <a:t>-Necesito más detalles de como se realiza el proceso de cálculo de transporte de los  sedimentos (Descripción del negocio)</a:t>
-            </a:r>
-          </a:p>
-          <a:p>
-            <a:endParaRPr lang="es-ES" sz="4000" dirty="0"/>
-          </a:p>
-          <a:p>
-            <a:r>
-              <a:rPr lang="es-ES" sz="4000" dirty="0"/>
-              <a:t>-NO TENGO COMPUTADORA PERSONAL DEPENDO DE OTRAS PERSONAS </a:t>
-            </a:r>
-          </a:p>
-          <a:p>
+            <a:pPr marL="571500" indent="-571500">
+              <a:buFontTx/>
+              <a:buChar char="-"/>
+            </a:pPr>
             <a:endParaRPr lang="es-ES" sz="4000" dirty="0"/>
           </a:p>
         </p:txBody>
@@ -9447,7 +8818,7 @@
 </p:sld>
 </file>
 
-<file path=ppt/slides/slide8.xml><?xml version="1.0" encoding="utf-8"?>
+<file path=ppt/slides/slide7.xml><?xml version="1.0" encoding="utf-8"?>
 <p:sld xmlns:a="http://schemas.openxmlformats.org/drawingml/2006/main" xmlns:r="http://schemas.openxmlformats.org/officeDocument/2006/relationships" xmlns:p="http://schemas.openxmlformats.org/presentationml/2006/main">
   <p:cSld>
     <p:spTree>
@@ -9746,7 +9117,7 @@
 </p:sld>
 </file>
 
-<file path=ppt/slides/slide9.xml><?xml version="1.0" encoding="utf-8"?>
+<file path=ppt/slides/slide8.xml><?xml version="1.0" encoding="utf-8"?>
 <p:sld xmlns:a="http://schemas.openxmlformats.org/drawingml/2006/main" xmlns:r="http://schemas.openxmlformats.org/officeDocument/2006/relationships" xmlns:p="http://schemas.openxmlformats.org/presentationml/2006/main">
   <p:cSld>
     <p:spTree>
@@ -9987,6 +9358,228 @@
     <p:extLst>
       <p:ext uri="{BB962C8B-B14F-4D97-AF65-F5344CB8AC3E}">
         <p14:creationId xmlns:p14="http://schemas.microsoft.com/office/powerpoint/2010/main" val="220410271"/>
+      </p:ext>
+    </p:extLst>
+  </p:cSld>
+  <p:clrMapOvr>
+    <a:masterClrMapping/>
+  </p:clrMapOvr>
+</p:sld>
+</file>
+
+<file path=ppt/slides/slide9.xml><?xml version="1.0" encoding="utf-8"?>
+<p:sld xmlns:a="http://schemas.openxmlformats.org/drawingml/2006/main" xmlns:r="http://schemas.openxmlformats.org/officeDocument/2006/relationships" xmlns:p="http://schemas.openxmlformats.org/presentationml/2006/main">
+  <p:cSld>
+    <p:spTree>
+      <p:nvGrpSpPr>
+        <p:cNvPr id="1" name="Shape 217"/>
+        <p:cNvGrpSpPr/>
+        <p:nvPr/>
+      </p:nvGrpSpPr>
+      <p:grpSpPr>
+        <a:xfrm>
+          <a:off x="0" y="0"/>
+          <a:ext cx="0" cy="0"/>
+          <a:chOff x="0" y="0"/>
+          <a:chExt cx="0" cy="0"/>
+        </a:xfrm>
+      </p:grpSpPr>
+      <p:sp>
+        <p:nvSpPr>
+          <p:cNvPr id="218" name="Google Shape;218;p25"/>
+          <p:cNvSpPr/>
+          <p:nvPr/>
+        </p:nvSpPr>
+        <p:spPr>
+          <a:xfrm>
+            <a:off x="0" y="-103451"/>
+            <a:ext cx="8529633" cy="10493903"/>
+          </a:xfrm>
+          <a:prstGeom prst="rect">
+            <a:avLst/>
+          </a:prstGeom>
+          <a:gradFill>
+            <a:gsLst>
+              <a:gs pos="0">
+                <a:srgbClr val="14C5C3"/>
+              </a:gs>
+              <a:gs pos="100000">
+                <a:srgbClr val="4E7AD9"/>
+              </a:gs>
+            </a:gsLst>
+            <a:lin ang="2700000" scaled="0"/>
+          </a:gradFill>
+          <a:ln>
+            <a:noFill/>
+          </a:ln>
+        </p:spPr>
+        <p:txBody>
+          <a:bodyPr spcFirstLastPara="1" wrap="square" lIns="91425" tIns="91425" rIns="91425" bIns="91425" anchor="ctr" anchorCtr="0">
+            <a:noAutofit/>
+          </a:bodyPr>
+          <a:lstStyle/>
+          <a:p>
+            <a:pPr marL="0" lvl="0" indent="0" algn="l" rtl="0">
+              <a:spcBef>
+                <a:spcPts val="0"/>
+              </a:spcBef>
+              <a:spcAft>
+                <a:spcPts val="0"/>
+              </a:spcAft>
+              <a:buNone/>
+            </a:pPr>
+            <a:endParaRPr/>
+          </a:p>
+        </p:txBody>
+      </p:sp>
+      <p:sp>
+        <p:nvSpPr>
+          <p:cNvPr id="221" name="Google Shape;221;p25"/>
+          <p:cNvSpPr txBox="1"/>
+          <p:nvPr/>
+        </p:nvSpPr>
+        <p:spPr>
+          <a:xfrm>
+            <a:off x="8749553" y="1884979"/>
+            <a:ext cx="9538447" cy="3570208"/>
+          </a:xfrm>
+          <a:prstGeom prst="rect">
+            <a:avLst/>
+          </a:prstGeom>
+          <a:noFill/>
+          <a:ln>
+            <a:noFill/>
+          </a:ln>
+        </p:spPr>
+        <p:txBody>
+          <a:bodyPr spcFirstLastPara="1" wrap="square" lIns="0" tIns="0" rIns="0" bIns="0" anchor="t" anchorCtr="0">
+            <a:spAutoFit/>
+          </a:bodyPr>
+          <a:lstStyle/>
+          <a:p>
+            <a:r>
+              <a:rPr lang="es-ES" sz="4800" dirty="0"/>
+              <a:t>Si todo esto que te he dicho te parece interesante te invito que seas parte de esta investigación</a:t>
+            </a:r>
+          </a:p>
+          <a:p>
+            <a:endParaRPr lang="es-ES" sz="2800" dirty="0"/>
+          </a:p>
+          <a:p>
+            <a:r>
+              <a:rPr lang="es-ES" sz="6000" dirty="0" err="1">
+                <a:solidFill>
+                  <a:srgbClr val="0070C0"/>
+                </a:solidFill>
+              </a:rPr>
+              <a:t>MoreCoasts</a:t>
+            </a:r>
+            <a:r>
+              <a:rPr lang="es-ES" sz="6000">
+                <a:solidFill>
+                  <a:srgbClr val="0070C0"/>
+                </a:solidFill>
+              </a:rPr>
+              <a:t> cuida </a:t>
+            </a:r>
+            <a:r>
+              <a:rPr lang="es-ES" sz="6000" dirty="0">
+                <a:solidFill>
+                  <a:srgbClr val="0070C0"/>
+                </a:solidFill>
+              </a:rPr>
+              <a:t>tu playa</a:t>
+            </a:r>
+          </a:p>
+        </p:txBody>
+      </p:sp>
+      <p:pic>
+        <p:nvPicPr>
+          <p:cNvPr id="6" name="Imagen 5"/>
+          <p:cNvPicPr>
+            <a:picLocks noChangeAspect="1"/>
+          </p:cNvPicPr>
+          <p:nvPr/>
+        </p:nvPicPr>
+        <p:blipFill>
+          <a:blip r:embed="rId3" cstate="print">
+            <a:extLst>
+              <a:ext uri="{28A0092B-C50C-407E-A947-70E740481C1C}">
+                <a14:useLocalDpi xmlns:a14="http://schemas.microsoft.com/office/drawing/2010/main" val="0"/>
+              </a:ext>
+            </a:extLst>
+          </a:blip>
+          <a:stretch>
+            <a:fillRect/>
+          </a:stretch>
+        </p:blipFill>
+        <p:spPr>
+          <a:xfrm>
+            <a:off x="914400" y="4207475"/>
+            <a:ext cx="1834307" cy="1872050"/>
+          </a:xfrm>
+          <a:prstGeom prst="rect">
+            <a:avLst/>
+          </a:prstGeom>
+        </p:spPr>
+      </p:pic>
+      <p:sp>
+        <p:nvSpPr>
+          <p:cNvPr id="7" name="Google Shape;88;p13"/>
+          <p:cNvSpPr txBox="1"/>
+          <p:nvPr/>
+        </p:nvSpPr>
+        <p:spPr>
+          <a:xfrm>
+            <a:off x="-2320422" y="4681835"/>
+            <a:ext cx="9712800" cy="923330"/>
+          </a:xfrm>
+          <a:prstGeom prst="rect">
+            <a:avLst/>
+          </a:prstGeom>
+          <a:noFill/>
+          <a:ln>
+            <a:noFill/>
+          </a:ln>
+        </p:spPr>
+        <p:txBody>
+          <a:bodyPr spcFirstLastPara="1" wrap="square" lIns="0" tIns="0" rIns="0" bIns="0" anchor="t" anchorCtr="0">
+            <a:spAutoFit/>
+          </a:bodyPr>
+          <a:lstStyle/>
+          <a:p>
+            <a:pPr marL="0" marR="0" lvl="0" indent="0" algn="r" rtl="0">
+              <a:lnSpc>
+                <a:spcPct val="100000"/>
+              </a:lnSpc>
+              <a:spcBef>
+                <a:spcPts val="0"/>
+              </a:spcBef>
+              <a:spcAft>
+                <a:spcPts val="0"/>
+              </a:spcAft>
+              <a:buNone/>
+            </a:pPr>
+            <a:r>
+              <a:rPr lang="es-ES" sz="6000" b="1" i="0" u="none" strike="noStrike" cap="none" dirty="0" err="1">
+                <a:solidFill>
+                  <a:srgbClr val="FFFFFF"/>
+                </a:solidFill>
+                <a:latin typeface="Poppins"/>
+                <a:ea typeface="Poppins"/>
+                <a:cs typeface="Poppins"/>
+                <a:sym typeface="Poppins"/>
+              </a:rPr>
+              <a:t>MoreCoast</a:t>
+            </a:r>
+            <a:endParaRPr sz="800" dirty="0"/>
+          </a:p>
+        </p:txBody>
+      </p:sp>
+    </p:spTree>
+    <p:extLst>
+      <p:ext uri="{BB962C8B-B14F-4D97-AF65-F5344CB8AC3E}">
+        <p14:creationId xmlns:p14="http://schemas.microsoft.com/office/powerpoint/2010/main" val="3689913601"/>
       </p:ext>
     </p:extLst>
   </p:cSld>

</xml_diff>